<commit_message>
Sharpen the judge-facing story: DPDP framing, comparison table, HP OmniBook target naming
The README now names the X Elite as the silicon inside HP OmniBook AI PCs,
adds a DPDP Act 2023 compliance argument for on-device redaction, and a
four-row comparison table (cloud APIs / generic NER / regex / Redacta).
npu.md 2b gets a skim-proof TL;DR framing the fp16 finding honestly; the
pitch deck names the target device class on the Snapdragon slide.

🤖 Generated with Codebuff
Co-Authored-By: Codebuff <noreply@codebuff.com>
</commit_message>
<xml_diff>
--- a/docs/Redacta_AI_Pitch.pptx
+++ b/docs/Redacta_AI_Pitch.pptx
@@ -5936,7 +5936,7 @@
                 </a:solidFill>
                 <a:latin typeface="Segoe UI"/>
               </a:rPr>
-              <a:t>Compiled and executed on the real X Elite NPU</a:t>
+              <a:t>Executed on the X Elite HTP — the silicon inside HP OmniBook AI PCs</a:t>
             </a:r>
           </a:p>
         </p:txBody>
@@ -6036,7 +6036,7 @@
                 </a:solidFill>
                 <a:latin typeface="Segoe UI"/>
               </a:rPr>
-              <a:t>GLiNER-PII → ONNX (static shapes) → QNN context binary → Snapdragon X Elite CRD (Hexagon v73) via AI Hub.</a:t>
+              <a:t>GLiNER-PII → ONNX (static shapes) → QNN context binary → Hexagon NPU (Snapdragon X Elite CRD) via AI Hub — the same silicon inside HP OmniBook AI PCs, the challenge's target device class.</a:t>
             </a:r>
           </a:p>
           <a:p>
@@ -6138,7 +6138,7 @@
                 </a:solidFill>
                 <a:latin typeface="Segoe UI"/>
               </a:rPr>
-              <a:t>17.7 s cold → 1.2 s warm; every load/inference step logged by the device runtime.</a:t>
+              <a:t>17.7 s cold → 1.2 s warm on target model mq2651d0n; every step logged by the device runtime.</a:t>
             </a:r>
           </a:p>
         </p:txBody>

</xml_diff>